<commit_message>
Actualiza presentacion final en evidencias grupales
</commit_message>
<xml_diff>
--- a/Fase 2/Evidencias Grupales/ETH_MAS_presentacion_final.pptx
+++ b/Fase 2/Evidencias Grupales/ETH_MAS_presentacion_final.pptx
@@ -6311,7 +6311,7 @@
                   <a:srgbClr val="0F172A"/>
                 </a:solidFill>
               </a:rPr>
-              <a:t>Integrante 1</a:t>
+              <a:t>David</a:t>
             </a:r>
             <a:endParaRPr lang="en-US" sz="1500" dirty="0"/>
           </a:p>
@@ -6410,7 +6410,7 @@
           <a:bodyPr/>
           <a:lstStyle/>
           <a:p>
-            <a:endParaRPr lang="es-CL"/>
+            <a:endParaRPr lang="es-CL" dirty="0"/>
           </a:p>
         </p:txBody>
       </p:sp>
@@ -6471,12 +6471,12 @@
               <a:buNone/>
             </a:pPr>
             <a:r>
-              <a:rPr lang="en-US" sz="1500" b="1" dirty="0">
+              <a:rPr lang="en-US" sz="1500" b="1" dirty="0" err="1">
                 <a:solidFill>
                   <a:srgbClr val="0F172A"/>
                 </a:solidFill>
               </a:rPr>
-              <a:t>Integrante 2</a:t>
+              <a:t>Yerson</a:t>
             </a:r>
             <a:endParaRPr lang="en-US" sz="1500" dirty="0"/>
           </a:p>
@@ -6641,7 +6641,7 @@
                   <a:srgbClr val="0F172A"/>
                 </a:solidFill>
               </a:rPr>
-              <a:t>Integrante 3</a:t>
+              <a:t>Rodrigo</a:t>
             </a:r>
             <a:endParaRPr lang="en-US" sz="1500" dirty="0"/>
           </a:p>

</xml_diff>